<commit_message>
Final decks: work in progress
Co-Authored-By: Claude Opus 5.5 <noreply@anthropic.com>
Claude-Session: https://claude.ai/code/session_01Q1YFQVkqvZuZSxHETxCkHf
</commit_message>
<xml_diff>
--- a/decks/client/knock-client-deck.pptx
+++ b/decks/client/knock-client-deck.pptx
@@ -883,10 +883,10 @@
         </p:nvGrpSpPr>
         <p:grpSpPr>
           <a:xfrm>
-            <a:off x="9067800" y="857250"/>
-            <a:ext cx="2266950" cy="2705100"/>
-            <a:chOff x="9067800" y="857250"/>
-            <a:chExt cx="2266950" cy="2705100"/>
+            <a:off x="9029700" y="857250"/>
+            <a:ext cx="2305050" cy="2743200"/>
+            <a:chOff x="9029700" y="857250"/>
+            <a:chExt cx="2305050" cy="2743200"/>
           </a:xfrm>
         </p:grpSpPr>
         <p:sp>
@@ -1149,8 +1149,8 @@
           </p:nvSpPr>
           <p:spPr>
             <a:xfrm>
-              <a:off x="9067800" y="2609850"/>
-              <a:ext cx="952500" cy="952500"/>
+              <a:off x="9029700" y="2571750"/>
+              <a:ext cx="1028700" cy="1028700"/>
             </a:xfrm>
             <a:prstGeom prst="ellipse">
               <a:avLst/>
@@ -1177,10 +1177,10 @@
           </p:nvGrpSpPr>
           <p:grpSpPr>
             <a:xfrm>
-              <a:off x="9099801" y="2844800"/>
-              <a:ext cx="888498" cy="534543"/>
-              <a:chOff x="9099801" y="2844800"/>
-              <a:chExt cx="888498" cy="534543"/>
+              <a:off x="9182361" y="2889250"/>
+              <a:ext cx="723378" cy="447675"/>
+              <a:chOff x="9182361" y="2889250"/>
+              <a:chExt cx="723378" cy="447675"/>
             </a:xfrm>
           </p:grpSpPr>
           <p:sp>
@@ -1191,8 +1191,8 @@
             </p:nvSpPr>
             <p:spPr>
               <a:xfrm>
-                <a:off x="8781326" y="2844800"/>
-                <a:ext cx="1525448" cy="191643"/>
+                <a:off x="8886059" y="2889250"/>
+                <a:ext cx="1315983" cy="161925"/>
               </a:xfrm>
               <a:prstGeom prst="rect">
                 <a:avLst/>
@@ -1210,7 +1210,7 @@
               <a:p>
                 <a:pPr algn="ctr"/>
                 <a:r>
-                  <a:rPr lang="en-IN" sz="980" b="1" spc="112" dirty="0">
+                  <a:rPr lang="en-IN" sz="820" b="1" spc="75" dirty="0">
                     <a:solidFill>
                       <a:srgbClr val="0E1F3A">
                         <a:alphaMod val="70000"/>
@@ -1233,8 +1233,8 @@
             </p:nvSpPr>
             <p:spPr>
               <a:xfrm>
-                <a:off x="8776027" y="3016250"/>
-                <a:ext cx="1536047" cy="191643"/>
+                <a:off x="8883355" y="3032125"/>
+                <a:ext cx="1321391" cy="161925"/>
               </a:xfrm>
               <a:prstGeom prst="rect">
                 <a:avLst/>
@@ -1252,7 +1252,7 @@
               <a:p>
                 <a:pPr algn="ctr"/>
                 <a:r>
-                  <a:rPr lang="en-IN" sz="980" b="1" spc="112" dirty="0">
+                  <a:rPr lang="en-IN" sz="820" b="1" spc="75" dirty="0">
                     <a:solidFill>
                       <a:srgbClr val="0E1F3A">
                         <a:alphaMod val="70000"/>
@@ -1275,8 +1275,8 @@
             </p:nvSpPr>
             <p:spPr>
               <a:xfrm>
-                <a:off x="9044226" y="3187700"/>
-                <a:ext cx="999649" cy="191643"/>
+                <a:off x="9099115" y="3175000"/>
+                <a:ext cx="889870" cy="161925"/>
               </a:xfrm>
               <a:prstGeom prst="rect">
                 <a:avLst/>
@@ -1294,7 +1294,7 @@
               <a:p>
                 <a:pPr algn="ctr"/>
                 <a:r>
-                  <a:rPr lang="en-IN" sz="980" b="1" spc="112" dirty="0">
+                  <a:rPr lang="en-IN" sz="820" b="1" spc="75" dirty="0">
                     <a:solidFill>
                       <a:srgbClr val="0E1F3A">
                         <a:alphaMod val="70000"/>
@@ -2860,9 +2860,9 @@
         <p:grpSpPr>
           <a:xfrm>
             <a:off x="675132" y="2247900"/>
-            <a:ext cx="3134868" cy="2217166"/>
+            <a:ext cx="3134868" cy="2064766"/>
             <a:chOff x="675132" y="2247900"/>
-            <a:chExt cx="3134868" cy="2217166"/>
+            <a:chExt cx="3134868" cy="2064766"/>
           </a:xfrm>
         </p:grpSpPr>
         <p:sp>
@@ -2974,7 +2974,7 @@
           </p:nvSpPr>
           <p:spPr>
             <a:xfrm>
-              <a:off x="677799" y="3327400"/>
+              <a:off x="677799" y="3175000"/>
               <a:ext cx="3821128" cy="1137666"/>
             </a:xfrm>
             <a:prstGeom prst="rect">
@@ -3083,9 +3083,9 @@
         <p:grpSpPr>
           <a:xfrm>
             <a:off x="4066032" y="2247900"/>
-            <a:ext cx="3134868" cy="1940941"/>
+            <a:ext cx="3134868" cy="1788541"/>
             <a:chOff x="4066032" y="2247900"/>
-            <a:chExt cx="3134868" cy="1940941"/>
+            <a:chExt cx="3134868" cy="1788541"/>
           </a:xfrm>
         </p:grpSpPr>
         <p:sp>
@@ -3172,7 +3172,7 @@
           </p:nvSpPr>
           <p:spPr>
             <a:xfrm>
-              <a:off x="4068699" y="3327400"/>
+              <a:off x="4068699" y="3175000"/>
               <a:ext cx="3756227" cy="861441"/>
             </a:xfrm>
             <a:prstGeom prst="rect">
@@ -3260,9 +3260,9 @@
         <p:grpSpPr>
           <a:xfrm>
             <a:off x="7456932" y="2247900"/>
-            <a:ext cx="4049268" cy="2769616"/>
+            <a:ext cx="4049268" cy="2617216"/>
             <a:chOff x="7456932" y="2247900"/>
-            <a:chExt cx="4049268" cy="2769616"/>
+            <a:chExt cx="4049268" cy="2617216"/>
           </a:xfrm>
         </p:grpSpPr>
         <p:sp>
@@ -3349,7 +3349,7 @@
           </p:nvSpPr>
           <p:spPr>
             <a:xfrm>
-              <a:off x="7459599" y="3327400"/>
+              <a:off x="7459599" y="3175000"/>
               <a:ext cx="4703715" cy="1690116"/>
             </a:xfrm>
             <a:prstGeom prst="rect">
@@ -3887,9 +3887,9 @@
         </p:nvGrpSpPr>
         <p:grpSpPr>
           <a:xfrm>
-            <a:off x="752094" y="2978150"/>
+            <a:off x="752094" y="3073400"/>
             <a:ext cx="7594311" cy="381381"/>
-            <a:chOff x="752094" y="2978150"/>
+            <a:chOff x="752094" y="3073400"/>
             <a:chExt cx="7594311" cy="381381"/>
           </a:xfrm>
         </p:grpSpPr>
@@ -3901,7 +3901,7 @@
           </p:nvSpPr>
           <p:spPr>
             <a:xfrm>
-              <a:off x="752094" y="2978150"/>
+              <a:off x="752094" y="3073400"/>
               <a:ext cx="10253604" cy="381381"/>
             </a:xfrm>
             <a:prstGeom prst="rect">
@@ -3942,9 +3942,9 @@
         </p:nvGrpSpPr>
         <p:grpSpPr>
           <a:xfrm>
-            <a:off x="762000" y="3711575"/>
+            <a:off x="762000" y="3844925"/>
             <a:ext cx="4576837" cy="1160907"/>
-            <a:chOff x="762000" y="3711575"/>
+            <a:chOff x="762000" y="3844925"/>
             <a:chExt cx="4576837" cy="1160907"/>
           </a:xfrm>
         </p:grpSpPr>
@@ -3956,7 +3956,7 @@
           </p:nvSpPr>
           <p:spPr>
             <a:xfrm>
-              <a:off x="762000" y="3714750"/>
+              <a:off x="762000" y="3848100"/>
               <a:ext cx="266700" cy="266700"/>
             </a:xfrm>
             <a:prstGeom prst="ellipse">
@@ -3978,7 +3978,7 @@
           </p:nvSpPr>
           <p:spPr>
             <a:xfrm>
-              <a:off x="642912" y="3756025"/>
+              <a:off x="642912" y="3889375"/>
               <a:ext cx="504878" cy="220028"/>
             </a:xfrm>
             <a:prstGeom prst="rect">
@@ -4018,7 +4018,7 @@
           </p:nvSpPr>
           <p:spPr>
             <a:xfrm>
-              <a:off x="1191768" y="3711575"/>
+              <a:off x="1191768" y="3844925"/>
               <a:ext cx="5102796" cy="322707"/>
             </a:xfrm>
             <a:prstGeom prst="rect">
@@ -4058,7 +4058,7 @@
           </p:nvSpPr>
           <p:spPr>
             <a:xfrm>
-              <a:off x="762000" y="4133850"/>
+              <a:off x="762000" y="4267200"/>
               <a:ext cx="266700" cy="266700"/>
             </a:xfrm>
             <a:prstGeom prst="ellipse">
@@ -4080,7 +4080,7 @@
           </p:nvSpPr>
           <p:spPr>
             <a:xfrm>
-              <a:off x="642912" y="4175125"/>
+              <a:off x="642912" y="4308475"/>
               <a:ext cx="504878" cy="220028"/>
             </a:xfrm>
             <a:prstGeom prst="rect">
@@ -4120,7 +4120,7 @@
           </p:nvSpPr>
           <p:spPr>
             <a:xfrm>
-              <a:off x="1191768" y="4130675"/>
+              <a:off x="1191768" y="4264025"/>
               <a:ext cx="5772189" cy="322707"/>
             </a:xfrm>
             <a:prstGeom prst="rect">
@@ -4160,7 +4160,7 @@
           </p:nvSpPr>
           <p:spPr>
             <a:xfrm>
-              <a:off x="762000" y="4552950"/>
+              <a:off x="762000" y="4686300"/>
               <a:ext cx="266700" cy="266700"/>
             </a:xfrm>
             <a:prstGeom prst="ellipse">
@@ -4182,7 +4182,7 @@
           </p:nvSpPr>
           <p:spPr>
             <a:xfrm>
-              <a:off x="642912" y="4594225"/>
+              <a:off x="642912" y="4727575"/>
               <a:ext cx="504878" cy="220028"/>
             </a:xfrm>
             <a:prstGeom prst="rect">
@@ -4222,7 +4222,7 @@
           </p:nvSpPr>
           <p:spPr>
             <a:xfrm>
-              <a:off x="1191768" y="4549775"/>
+              <a:off x="1191768" y="4683125"/>
               <a:ext cx="5764933" cy="322707"/>
             </a:xfrm>
             <a:prstGeom prst="rect">
@@ -4263,9 +4263,9 @@
         </p:nvGrpSpPr>
         <p:grpSpPr>
           <a:xfrm>
-            <a:off x="762000" y="5219700"/>
+            <a:off x="762000" y="5276850"/>
             <a:ext cx="6158103" cy="652907"/>
-            <a:chOff x="762000" y="5219700"/>
+            <a:chOff x="762000" y="5276850"/>
             <a:chExt cx="6158103" cy="652907"/>
           </a:xfrm>
         </p:grpSpPr>
@@ -4277,7 +4277,7 @@
           </p:nvSpPr>
           <p:spPr>
             <a:xfrm>
-              <a:off x="762000" y="5219700"/>
+              <a:off x="762000" y="5276850"/>
               <a:ext cx="2857500" cy="571500"/>
             </a:xfrm>
             <a:prstGeom prst="rect">
@@ -4299,7 +4299,7 @@
           </p:nvSpPr>
           <p:spPr>
             <a:xfrm>
-              <a:off x="215643" y="5346700"/>
+              <a:off x="215643" y="5403850"/>
               <a:ext cx="3950215" cy="410718"/>
             </a:xfrm>
             <a:prstGeom prst="rect">
@@ -4339,7 +4339,7 @@
           </p:nvSpPr>
           <p:spPr>
             <a:xfrm>
-              <a:off x="3915918" y="5264150"/>
+              <a:off x="3915918" y="5321300"/>
               <a:ext cx="4286440" cy="322707"/>
             </a:xfrm>
             <a:prstGeom prst="rect">
@@ -4379,7 +4379,7 @@
           </p:nvSpPr>
           <p:spPr>
             <a:xfrm>
-              <a:off x="3915918" y="5549900"/>
+              <a:off x="3915918" y="5607050"/>
               <a:ext cx="2979250" cy="322707"/>
             </a:xfrm>
             <a:prstGeom prst="rect">
@@ -4420,9 +4420,9 @@
         </p:nvGrpSpPr>
         <p:grpSpPr>
           <a:xfrm>
-            <a:off x="756666" y="6216650"/>
+            <a:off x="756666" y="6235700"/>
             <a:ext cx="4302402" cy="205359"/>
-            <a:chOff x="756666" y="6216650"/>
+            <a:chOff x="756666" y="6235700"/>
             <a:chExt cx="4302402" cy="205359"/>
           </a:xfrm>
         </p:grpSpPr>
@@ -4434,7 +4434,7 @@
           </p:nvSpPr>
           <p:spPr>
             <a:xfrm>
-              <a:off x="756666" y="6216650"/>
+              <a:off x="756666" y="6235700"/>
               <a:ext cx="5974122" cy="205359"/>
             </a:xfrm>
             <a:prstGeom prst="rect">
@@ -4475,10 +4475,10 @@
         </p:nvGrpSpPr>
         <p:grpSpPr>
           <a:xfrm>
-            <a:off x="9067800" y="857250"/>
-            <a:ext cx="2266950" cy="2705100"/>
-            <a:chOff x="9067800" y="857250"/>
-            <a:chExt cx="2266950" cy="2705100"/>
+            <a:off x="9029700" y="857250"/>
+            <a:ext cx="2305050" cy="2743200"/>
+            <a:chOff x="9029700" y="857250"/>
+            <a:chExt cx="2305050" cy="2743200"/>
           </a:xfrm>
         </p:grpSpPr>
         <p:sp>
@@ -4741,8 +4741,8 @@
           </p:nvSpPr>
           <p:spPr>
             <a:xfrm>
-              <a:off x="9067800" y="2609850"/>
-              <a:ext cx="952500" cy="952500"/>
+              <a:off x="9029700" y="2571750"/>
+              <a:ext cx="1028700" cy="1028700"/>
             </a:xfrm>
             <a:prstGeom prst="ellipse">
               <a:avLst/>
@@ -4769,10 +4769,10 @@
           </p:nvGrpSpPr>
           <p:grpSpPr>
             <a:xfrm>
-              <a:off x="9099801" y="2844800"/>
-              <a:ext cx="888498" cy="534543"/>
-              <a:chOff x="9099801" y="2844800"/>
-              <a:chExt cx="888498" cy="534543"/>
+              <a:off x="9182361" y="2889250"/>
+              <a:ext cx="723378" cy="447675"/>
+              <a:chOff x="9182361" y="2889250"/>
+              <a:chExt cx="723378" cy="447675"/>
             </a:xfrm>
           </p:grpSpPr>
           <p:sp>
@@ -4783,8 +4783,8 @@
             </p:nvSpPr>
             <p:spPr>
               <a:xfrm>
-                <a:off x="8781326" y="2844800"/>
-                <a:ext cx="1525448" cy="191643"/>
+                <a:off x="8886059" y="2889250"/>
+                <a:ext cx="1315983" cy="161925"/>
               </a:xfrm>
               <a:prstGeom prst="rect">
                 <a:avLst/>
@@ -4802,7 +4802,7 @@
               <a:p>
                 <a:pPr algn="ctr"/>
                 <a:r>
-                  <a:rPr lang="en-IN" sz="980" b="1" spc="112" dirty="0">
+                  <a:rPr lang="en-IN" sz="820" b="1" spc="75" dirty="0">
                     <a:solidFill>
                       <a:srgbClr val="0E1F3A">
                         <a:alphaMod val="70000"/>
@@ -4825,8 +4825,8 @@
             </p:nvSpPr>
             <p:spPr>
               <a:xfrm>
-                <a:off x="8776027" y="3016250"/>
-                <a:ext cx="1536047" cy="191643"/>
+                <a:off x="8883355" y="3032125"/>
+                <a:ext cx="1321391" cy="161925"/>
               </a:xfrm>
               <a:prstGeom prst="rect">
                 <a:avLst/>
@@ -4844,7 +4844,7 @@
               <a:p>
                 <a:pPr algn="ctr"/>
                 <a:r>
-                  <a:rPr lang="en-IN" sz="980" b="1" spc="112" dirty="0">
+                  <a:rPr lang="en-IN" sz="820" b="1" spc="75" dirty="0">
                     <a:solidFill>
                       <a:srgbClr val="0E1F3A">
                         <a:alphaMod val="70000"/>
@@ -4867,8 +4867,8 @@
             </p:nvSpPr>
             <p:spPr>
               <a:xfrm>
-                <a:off x="9044226" y="3187700"/>
-                <a:ext cx="999649" cy="191643"/>
+                <a:off x="9099115" y="3175000"/>
+                <a:ext cx="889870" cy="161925"/>
               </a:xfrm>
               <a:prstGeom prst="rect">
                 <a:avLst/>
@@ -4886,7 +4886,7 @@
               <a:p>
                 <a:pPr algn="ctr"/>
                 <a:r>
-                  <a:rPr lang="en-IN" sz="980" b="1" spc="112" dirty="0">
+                  <a:rPr lang="en-IN" sz="820" b="1" spc="75" dirty="0">
                     <a:solidFill>
                       <a:srgbClr val="0E1F3A">
                         <a:alphaMod val="70000"/>
@@ -7486,9 +7486,9 @@
         <p:grpSpPr>
           <a:xfrm>
             <a:off x="685800" y="2209800"/>
-            <a:ext cx="5029200" cy="2933700"/>
+            <a:ext cx="5029200" cy="3086100"/>
             <a:chOff x="685800" y="2209800"/>
-            <a:chExt cx="5029200" cy="2933700"/>
+            <a:chExt cx="5029200" cy="3086100"/>
           </a:xfrm>
         </p:grpSpPr>
         <p:sp>
@@ -7500,7 +7500,7 @@
           <p:spPr>
             <a:xfrm>
               <a:off x="685800" y="2209800"/>
-              <a:ext cx="5029200" cy="2933700"/>
+              <a:ext cx="5029200" cy="3086100"/>
             </a:xfrm>
             <a:prstGeom prst="rect">
               <a:avLst/>
@@ -7943,7 +7943,7 @@
           </p:nvSpPr>
           <p:spPr>
             <a:xfrm>
-              <a:off x="945261" y="4591050"/>
+              <a:off x="945261" y="4667250"/>
               <a:ext cx="4540066" cy="526352"/>
             </a:xfrm>
             <a:prstGeom prst="rect">
@@ -8010,9 +8010,9 @@
         <p:grpSpPr>
           <a:xfrm>
             <a:off x="6096000" y="2209800"/>
-            <a:ext cx="5410200" cy="2945702"/>
+            <a:ext cx="5410200" cy="3086100"/>
             <a:chOff x="6096000" y="2209800"/>
-            <a:chExt cx="5410200" cy="2945702"/>
+            <a:chExt cx="5410200" cy="3086100"/>
           </a:xfrm>
         </p:grpSpPr>
         <p:sp>
@@ -8024,7 +8024,7 @@
           <p:spPr>
             <a:xfrm>
               <a:off x="6096000" y="2209800"/>
-              <a:ext cx="5410200" cy="2933700"/>
+              <a:ext cx="5410200" cy="3086100"/>
             </a:xfrm>
             <a:prstGeom prst="rect">
               <a:avLst/>
@@ -8314,7 +8314,7 @@
           </p:nvSpPr>
           <p:spPr>
             <a:xfrm>
-              <a:off x="6355461" y="4629150"/>
+              <a:off x="6355461" y="4667250"/>
               <a:ext cx="4696862" cy="526352"/>
             </a:xfrm>
             <a:prstGeom prst="rect">
@@ -8380,9 +8380,9 @@
         </p:nvGrpSpPr>
         <p:grpSpPr>
           <a:xfrm>
-            <a:off x="675894" y="5359400"/>
+            <a:off x="675894" y="5492750"/>
             <a:ext cx="7508055" cy="743331"/>
-            <a:chOff x="675894" y="5359400"/>
+            <a:chOff x="675894" y="5492750"/>
             <a:chExt cx="7508055" cy="743331"/>
           </a:xfrm>
         </p:grpSpPr>
@@ -8394,7 +8394,7 @@
           </p:nvSpPr>
           <p:spPr>
             <a:xfrm>
-              <a:off x="675894" y="5359400"/>
+              <a:off x="675894" y="5492750"/>
               <a:ext cx="10141471" cy="743331"/>
             </a:xfrm>
             <a:prstGeom prst="rect">
@@ -12208,7 +12208,7 @@
           </p:nvSpPr>
           <p:spPr>
             <a:xfrm>
-              <a:off x="942594" y="3149600"/>
+              <a:off x="942594" y="3111500"/>
               <a:ext cx="2137025" cy="381381"/>
             </a:xfrm>
             <a:prstGeom prst="rect">
@@ -12248,7 +12248,7 @@
           </p:nvSpPr>
           <p:spPr>
             <a:xfrm>
-              <a:off x="990600" y="3609975"/>
+              <a:off x="990600" y="3571875"/>
               <a:ext cx="266700" cy="266700"/>
             </a:xfrm>
             <a:prstGeom prst="ellipse">
@@ -12270,7 +12270,7 @@
           </p:nvSpPr>
           <p:spPr>
             <a:xfrm>
-              <a:off x="871512" y="3651250"/>
+              <a:off x="871512" y="3613150"/>
               <a:ext cx="504878" cy="220028"/>
             </a:xfrm>
             <a:prstGeom prst="rect">
@@ -12310,8 +12310,8 @@
           </p:nvSpPr>
           <p:spPr>
             <a:xfrm>
-              <a:off x="1514094" y="3575050"/>
-              <a:ext cx="4233716" cy="724281"/>
+              <a:off x="1514094" y="3536950"/>
+              <a:ext cx="4233716" cy="705231"/>
             </a:xfrm>
             <a:prstGeom prst="rect">
               <a:avLst/>
@@ -12329,7 +12329,7 @@
             <a:p>
               <a:pPr algn="l">
                 <a:lnSpc>
-                  <a:spcPts val="2700"/>
+                  <a:spcPts val="2550"/>
                 </a:lnSpc>
               </a:pPr>
               <a:r>
@@ -12375,7 +12375,7 @@
           </p:nvSpPr>
           <p:spPr>
             <a:xfrm>
-              <a:off x="990600" y="4410075"/>
+              <a:off x="990600" y="4352925"/>
               <a:ext cx="266700" cy="266700"/>
             </a:xfrm>
             <a:prstGeom prst="ellipse">
@@ -12397,7 +12397,7 @@
           </p:nvSpPr>
           <p:spPr>
             <a:xfrm>
-              <a:off x="871512" y="4451350"/>
+              <a:off x="871512" y="4394200"/>
               <a:ext cx="504878" cy="220028"/>
             </a:xfrm>
             <a:prstGeom prst="rect">
@@ -12437,8 +12437,8 @@
           </p:nvSpPr>
           <p:spPr>
             <a:xfrm>
-              <a:off x="1514094" y="4375150"/>
-              <a:ext cx="3808749" cy="724281"/>
+              <a:off x="1514094" y="4318000"/>
+              <a:ext cx="3808749" cy="705231"/>
             </a:xfrm>
             <a:prstGeom prst="rect">
               <a:avLst/>
@@ -12456,7 +12456,7 @@
             <a:p>
               <a:pPr algn="l">
                 <a:lnSpc>
-                  <a:spcPts val="2700"/>
+                  <a:spcPts val="2550"/>
                 </a:lnSpc>
               </a:pPr>
               <a:r>
@@ -12502,7 +12502,7 @@
           </p:nvSpPr>
           <p:spPr>
             <a:xfrm>
-              <a:off x="990600" y="5210175"/>
+              <a:off x="990600" y="5133975"/>
               <a:ext cx="266700" cy="266700"/>
             </a:xfrm>
             <a:prstGeom prst="ellipse">
@@ -12524,7 +12524,7 @@
           </p:nvSpPr>
           <p:spPr>
             <a:xfrm>
-              <a:off x="871512" y="5251450"/>
+              <a:off x="871512" y="5175250"/>
               <a:ext cx="504878" cy="220028"/>
             </a:xfrm>
             <a:prstGeom prst="rect">
@@ -12564,8 +12564,8 @@
           </p:nvSpPr>
           <p:spPr>
             <a:xfrm>
-              <a:off x="1514094" y="5175250"/>
-              <a:ext cx="4278530" cy="724281"/>
+              <a:off x="1514094" y="5099050"/>
+              <a:ext cx="4278530" cy="705231"/>
             </a:xfrm>
             <a:prstGeom prst="rect">
               <a:avLst/>
@@ -12583,7 +12583,7 @@
             <a:p>
               <a:pPr algn="l">
                 <a:lnSpc>
-                  <a:spcPts val="2700"/>
+                  <a:spcPts val="2550"/>
                 </a:lnSpc>
               </a:pPr>
               <a:r>
@@ -12629,7 +12629,7 @@
           </p:nvSpPr>
           <p:spPr>
             <a:xfrm>
-              <a:off x="947547" y="5930900"/>
+              <a:off x="947547" y="5911850"/>
               <a:ext cx="3667180" cy="191643"/>
             </a:xfrm>
             <a:prstGeom prst="rect">
@@ -12671,9 +12671,9 @@
         <p:grpSpPr>
           <a:xfrm>
             <a:off x="7615047" y="2216150"/>
-            <a:ext cx="3535998" cy="3722370"/>
+            <a:ext cx="3535998" cy="3893820"/>
             <a:chOff x="7615047" y="2216150"/>
-            <a:chExt cx="3535998" cy="3722370"/>
+            <a:chExt cx="3535998" cy="3893820"/>
           </a:xfrm>
         </p:grpSpPr>
         <p:sp>
@@ -12927,9 +12927,9 @@
           </p:nvGrpSpPr>
           <p:grpSpPr>
             <a:xfrm>
-              <a:off x="7620000" y="3854450"/>
+              <a:off x="7620000" y="4006850"/>
               <a:ext cx="3531045" cy="902970"/>
-              <a:chOff x="7620000" y="3854450"/>
+              <a:chOff x="7620000" y="4006850"/>
               <a:chExt cx="3531045" cy="902970"/>
             </a:xfrm>
           </p:grpSpPr>
@@ -12941,7 +12941,7 @@
             </p:nvSpPr>
             <p:spPr>
               <a:xfrm>
-                <a:off x="7620000" y="3905250"/>
+                <a:off x="7620000" y="4057650"/>
                 <a:ext cx="266700" cy="266700"/>
               </a:xfrm>
               <a:prstGeom prst="ellipse">
@@ -12963,7 +12963,7 @@
             </p:nvSpPr>
             <p:spPr>
               <a:xfrm>
-                <a:off x="7500912" y="3946525"/>
+                <a:off x="7500912" y="4098925"/>
                 <a:ext cx="504878" cy="220028"/>
               </a:xfrm>
               <a:prstGeom prst="rect">
@@ -13003,7 +13003,7 @@
             </p:nvSpPr>
             <p:spPr>
               <a:xfrm>
-                <a:off x="8048244" y="3854450"/>
+                <a:off x="8048244" y="4006850"/>
                 <a:ext cx="4143756" cy="381381"/>
               </a:xfrm>
               <a:prstGeom prst="rect">
@@ -13043,7 +13043,7 @@
             </p:nvSpPr>
             <p:spPr>
               <a:xfrm>
-                <a:off x="8050530" y="4197350"/>
+                <a:off x="8050530" y="4349750"/>
                 <a:ext cx="4128043" cy="560070"/>
               </a:xfrm>
               <a:prstGeom prst="rect">
@@ -13109,9 +13109,9 @@
           </p:nvGrpSpPr>
           <p:grpSpPr>
             <a:xfrm>
-              <a:off x="7620000" y="5035550"/>
+              <a:off x="7620000" y="5207000"/>
               <a:ext cx="3338027" cy="902970"/>
-              <a:chOff x="7620000" y="5035550"/>
+              <a:chOff x="7620000" y="5207000"/>
               <a:chExt cx="3338027" cy="902970"/>
             </a:xfrm>
           </p:grpSpPr>
@@ -13123,7 +13123,7 @@
             </p:nvSpPr>
             <p:spPr>
               <a:xfrm>
-                <a:off x="7620000" y="5086350"/>
+                <a:off x="7620000" y="5257800"/>
                 <a:ext cx="266700" cy="266700"/>
               </a:xfrm>
               <a:prstGeom prst="ellipse">
@@ -13145,7 +13145,7 @@
             </p:nvSpPr>
             <p:spPr>
               <a:xfrm>
-                <a:off x="7500912" y="5127625"/>
+                <a:off x="7500912" y="5299075"/>
                 <a:ext cx="504878" cy="220028"/>
               </a:xfrm>
               <a:prstGeom prst="rect">
@@ -13185,7 +13185,7 @@
             </p:nvSpPr>
             <p:spPr>
               <a:xfrm>
-                <a:off x="8048244" y="5035550"/>
+                <a:off x="8048244" y="5207000"/>
                 <a:ext cx="4143756" cy="381381"/>
               </a:xfrm>
               <a:prstGeom prst="rect">
@@ -13225,7 +13225,7 @@
             </p:nvSpPr>
             <p:spPr>
               <a:xfrm>
-                <a:off x="8050530" y="5378450"/>
+                <a:off x="8050530" y="5549900"/>
                 <a:ext cx="3797926" cy="560070"/>
               </a:xfrm>
               <a:prstGeom prst="rect">
@@ -16996,7 +16996,7 @@
           </p:nvSpPr>
           <p:spPr>
             <a:xfrm>
-              <a:off x="3230880" y="5353050"/>
+              <a:off x="4183380" y="5353050"/>
               <a:ext cx="4629831" cy="541020"/>
             </a:xfrm>
             <a:prstGeom prst="rect">

</xml_diff>